<commit_message>
Publish narrated product demo and verified submission package
</commit_message>
<xml_diff>
--- a/deliverables/Pactshift-pitch.pptx
+++ b/deliverables/Pactshift-pitch.pptx
@@ -2,19 +2,19 @@
 <file path=ppt/presentation.xml><?xml version="1.0" encoding="utf-8"?>
 <p:presentation xmlns:p="http://schemas.openxmlformats.org/presentationml/2006/main">
   <p:sldMasterIdLst>
-    <p:sldMasterId xmlns:r="http://schemas.openxmlformats.org/officeDocument/2006/relationships" id="2147483648" r:id="R3f2493f41b5442cc"/>
+    <p:sldMasterId xmlns:r="http://schemas.openxmlformats.org/officeDocument/2006/relationships" id="2147483648" r:id="Rd3b696c6852149cd"/>
   </p:sldMasterIdLst>
   <p:notesMasterIdLst>
-    <p:notesMasterId xmlns:r="http://schemas.openxmlformats.org/officeDocument/2006/relationships" r:id="Rff4bf12b2f7841e6"/>
+    <p:notesMasterId xmlns:r="http://schemas.openxmlformats.org/officeDocument/2006/relationships" r:id="R557021933e9d4069"/>
   </p:notesMasterIdLst>
   <p:sldIdLst>
-    <p:sldId xmlns:r="http://schemas.openxmlformats.org/officeDocument/2006/relationships" id="256" r:id="Rd6939c8448a74890"/>
-    <p:sldId xmlns:r="http://schemas.openxmlformats.org/officeDocument/2006/relationships" id="257" r:id="R7cf719cd7dfe4cd8"/>
-    <p:sldId xmlns:r="http://schemas.openxmlformats.org/officeDocument/2006/relationships" id="258" r:id="R42660108ce314bd6"/>
-    <p:sldId xmlns:r="http://schemas.openxmlformats.org/officeDocument/2006/relationships" id="259" r:id="R3abf1718ff154813"/>
-    <p:sldId xmlns:r="http://schemas.openxmlformats.org/officeDocument/2006/relationships" id="260" r:id="Rc3bace86e9424c1c"/>
-    <p:sldId xmlns:r="http://schemas.openxmlformats.org/officeDocument/2006/relationships" id="261" r:id="R70c3b850be0d41c3"/>
-    <p:sldId xmlns:r="http://schemas.openxmlformats.org/officeDocument/2006/relationships" id="262" r:id="Raf8cad849c464ad8"/>
+    <p:sldId xmlns:r="http://schemas.openxmlformats.org/officeDocument/2006/relationships" id="256" r:id="Rac06287ef51940f8"/>
+    <p:sldId xmlns:r="http://schemas.openxmlformats.org/officeDocument/2006/relationships" id="257" r:id="R9d98bf1b64e24840"/>
+    <p:sldId xmlns:r="http://schemas.openxmlformats.org/officeDocument/2006/relationships" id="258" r:id="Re8a930e66a984457"/>
+    <p:sldId xmlns:r="http://schemas.openxmlformats.org/officeDocument/2006/relationships" id="259" r:id="Rcddf0e4f45244b87"/>
+    <p:sldId xmlns:r="http://schemas.openxmlformats.org/officeDocument/2006/relationships" id="260" r:id="R31cb18419f7548bd"/>
+    <p:sldId xmlns:r="http://schemas.openxmlformats.org/officeDocument/2006/relationships" id="261" r:id="Rd3b70d9f46bd406e"/>
+    <p:sldId xmlns:r="http://schemas.openxmlformats.org/officeDocument/2006/relationships" id="262" r:id="Ra9d60fa92daf44be"/>
   </p:sldIdLst>
   <p:sldSz cx="12192000" cy="6858000"/>
   <p:notesSz cx="6858000" cy="9144000"/>
@@ -658,7 +658,7 @@
           <a:lstStyle xmlns:a="http://schemas.openxmlformats.org/drawingml/2006/main"/>
           <a:p xmlns:a="http://schemas.openxmlformats.org/drawingml/2006/main">
             <a:r>
-              <a:t>Source: docs/images/request.png, a native browser capture from the working local Pactshift application. This slide crops the image to the request, scope evidence and proposed options. The demonstration workspace is fictional and isolated from real customer data. This is the owner review screen, not the client offer. The screenshot remains a raster image and the surrounding text remains editable. Live application: https://pactshift-wh46bdeima-uc.a.run.app</a:t>
+              <a:t>Source: docs/images/request.png, a native browser capture from the working local Pactshift application. This slide crops the image to the request, scope evidence and proposed options. The demonstration workspace is fictional and isolated from real customer data. This is the owner review screen, not the client offer. The screenshot remains a raster image and the surrounding text remains editable. Live application: https://pactshift.web.app</a:t>
             </a:r>
           </a:p>
         </p:txBody>
@@ -868,7 +868,7 @@
           <a:lstStyle xmlns:a="http://schemas.openxmlformats.org/drawingml/2006/main"/>
           <a:p xmlns:a="http://schemas.openxmlformats.org/drawingml/2006/main">
             <a:r>
-              <a:t>Commercial hypothesis: begin with small agencies selling web/design work at fixed fees. Recruit five design partners with consent, run real requests, and measure time to a client decision, accepted value, repeat use, and willingness to pay. These are planned validation steps, not completed traction. Competitive differentiation is the executable add/swap/defer baseline workflow with explicit capacity checks and a flat subscription. Similar products already exist, including ScopeGuardian, ScopeApproval, and ScopePilot. Source links and comparison limits: docs/MARKET.md. Founder and builder: Shivam Gupta. AI-assisted engineering and content production. Repository: https://github.com/shi1720/Galuxium-Nexus-V2. Live application: https://pactshift-wh46bdeima-uc.a.run.app</a:t>
+              <a:t>Commercial hypothesis: begin with small agencies selling web/design work at fixed fees. Recruit five design partners with consent, run real requests, and measure time to a client decision, accepted value, repeat use, and willingness to pay. These are planned validation steps, not completed traction. Competitive differentiation is the executable add/swap/defer baseline workflow with explicit capacity checks and a flat subscription. Similar products already exist, including ScopeGuardian, ScopeApproval, and ScopePilot. Source links and comparison limits: docs/MARKET.md. Founder and builder: Shivam Gupta. AI-assisted engineering and content production. Repository: https://github.com/shi1720/Galuxium-Nexus-V2. Live application: https://pactshift.web.app</a:t>
             </a:r>
           </a:p>
         </p:txBody>
@@ -936,7 +936,7 @@
   </p:cSld>
   <p:clrMap bg1="lt1" tx1="dk1" bg2="lt2" tx2="dk2" accent1="accent1" accent2="accent2" accent3="accent3" accent4="accent4" accent5="accent5" accent6="accent6" hlink="hlink" folHlink="folHlink"/>
   <p:sldLayoutIdLst>
-    <p:sldLayoutId xmlns:r="http://schemas.openxmlformats.org/officeDocument/2006/relationships" id="2147483649" r:id="R4cb3c96028cb4d23"/>
+    <p:sldLayoutId xmlns:r="http://schemas.openxmlformats.org/officeDocument/2006/relationships" id="2147483649" r:id="R23f0fc1f465247d8"/>
   </p:sldLayoutIdLst>
   <p:txStyles>
     <p:titleStyle>
@@ -1669,7 +1669,7 @@
           <p:cNvPr id="6" name="PACTSHIFT">
             <a:extLst xmlns:a="http://schemas.openxmlformats.org/drawingml/2006/main">
               <a:ext uri="{FF2B5EF4-FFF2-40B4-BE49-F238E27FC236}">
-                <a16:creationId xmlns:a16="http://schemas.microsoft.com/office/drawing/2014/main" id="{0398315D-C5FA-4EDB-8364-232ED0C03760}"/>
+                <a16:creationId xmlns:a16="http://schemas.microsoft.com/office/drawing/2014/main" id="{948F2807-27D6-49F4-9F54-2CE27F06E140}"/>
               </a:ext>
             </a:extLst>
           </p:cNvPr>
@@ -1726,7 +1726,7 @@
           <p:cNvPr id="2" name="01">
             <a:extLst xmlns:a="http://schemas.openxmlformats.org/drawingml/2006/main">
               <a:ext uri="{FF2B5EF4-FFF2-40B4-BE49-F238E27FC236}">
-                <a16:creationId xmlns:a16="http://schemas.microsoft.com/office/drawing/2014/main" id="{423E939C-4E57-489B-B472-F12A9249F2BE}"/>
+                <a16:creationId xmlns:a16="http://schemas.microsoft.com/office/drawing/2014/main" id="{9CC30D1A-82DB-4627-A1CF-A0B7EA02C397}"/>
               </a:ext>
             </a:extLst>
           </p:cNvPr>
@@ -1783,7 +1783,7 @@
           <p:cNvPr id="3" name="Pactshift">
             <a:extLst xmlns:a="http://schemas.openxmlformats.org/drawingml/2006/main">
               <a:ext uri="{FF2B5EF4-FFF2-40B4-BE49-F238E27FC236}">
-                <a16:creationId xmlns:a16="http://schemas.microsoft.com/office/drawing/2014/main" id="{3A109569-4C29-46C6-AC6F-1233C2EF5BD7}"/>
+                <a16:creationId xmlns:a16="http://schemas.microsoft.com/office/drawing/2014/main" id="{CA38F4BF-6657-4909-B15C-D9B10C0B8F48}"/>
               </a:ext>
             </a:extLst>
           </p:cNvPr>
@@ -1840,7 +1840,7 @@
           <p:cNvPr id="4" name="Scope changes your&#10;clients can approve">
             <a:extLst xmlns:a="http://schemas.openxmlformats.org/drawingml/2006/main">
               <a:ext uri="{FF2B5EF4-FFF2-40B4-BE49-F238E27FC236}">
-                <a16:creationId xmlns:a16="http://schemas.microsoft.com/office/drawing/2014/main" id="{486CB43F-F9F0-4358-8CE9-62E68A6BA212}"/>
+                <a16:creationId xmlns:a16="http://schemas.microsoft.com/office/drawing/2014/main" id="{D592D05D-5FF0-4BB2-B8F7-244823C4286D}"/>
               </a:ext>
             </a:extLst>
           </p:cNvPr>
@@ -1920,7 +1920,7 @@
           <p:cNvPr id="5" name="Shivam Gupta  /  Founder and builder">
             <a:extLst xmlns:a="http://schemas.openxmlformats.org/drawingml/2006/main">
               <a:ext uri="{FF2B5EF4-FFF2-40B4-BE49-F238E27FC236}">
-                <a16:creationId xmlns:a16="http://schemas.microsoft.com/office/drawing/2014/main" id="{CA7D8325-A9CB-4E5D-9EA9-61C82B24F72B}"/>
+                <a16:creationId xmlns:a16="http://schemas.microsoft.com/office/drawing/2014/main" id="{9CB606E6-E731-4A42-97F0-C7A1CFC7A99F}"/>
               </a:ext>
             </a:extLst>
           </p:cNvPr>
@@ -1975,7 +1975,7 @@
     </p:spTree>
     <p:extLst>
       <p:ext uri="{BB962C8B-B14F-4D97-AF65-F5344CB8AC3E}">
-        <p14:creationId xmlns:p14="http://schemas.microsoft.com/office/powerpoint/2010/main" val="450692456"/>
+        <p14:creationId xmlns:p14="http://schemas.microsoft.com/office/powerpoint/2010/main" val="674242334"/>
       </p:ext>
     </p:extLst>
   </p:cSld>
@@ -2006,7 +2006,7 @@
           <p:cNvPr id="10" name="PACTSHIFT">
             <a:extLst xmlns:a="http://schemas.openxmlformats.org/drawingml/2006/main">
               <a:ext uri="{FF2B5EF4-FFF2-40B4-BE49-F238E27FC236}">
-                <a16:creationId xmlns:a16="http://schemas.microsoft.com/office/drawing/2014/main" id="{F9DBBAC0-8468-4A7C-8A06-58F1F4B9FA11}"/>
+                <a16:creationId xmlns:a16="http://schemas.microsoft.com/office/drawing/2014/main" id="{6F510041-84A7-4F8E-8644-0B626B635FDE}"/>
               </a:ext>
             </a:extLst>
           </p:cNvPr>
@@ -2063,7 +2063,7 @@
           <p:cNvPr id="2" name="02">
             <a:extLst xmlns:a="http://schemas.openxmlformats.org/drawingml/2006/main">
               <a:ext uri="{FF2B5EF4-FFF2-40B4-BE49-F238E27FC236}">
-                <a16:creationId xmlns:a16="http://schemas.microsoft.com/office/drawing/2014/main" id="{DAA08ECF-934A-44FB-8B76-82DEBB20FBB3}"/>
+                <a16:creationId xmlns:a16="http://schemas.microsoft.com/office/drawing/2014/main" id="{F518E82F-DE37-4824-A3EB-92644EF11888}"/>
               </a:ext>
             </a:extLst>
           </p:cNvPr>
@@ -2120,7 +2120,7 @@
           <p:cNvPr id="3" name="The cost of “one more thing”">
             <a:extLst xmlns:a="http://schemas.openxmlformats.org/drawingml/2006/main">
               <a:ext uri="{FF2B5EF4-FFF2-40B4-BE49-F238E27FC236}">
-                <a16:creationId xmlns:a16="http://schemas.microsoft.com/office/drawing/2014/main" id="{B5DA0A88-5B04-48DF-B66F-B3561C1B788E}"/>
+                <a16:creationId xmlns:a16="http://schemas.microsoft.com/office/drawing/2014/main" id="{59E83DB4-8836-4EAE-A610-68F24D890628}"/>
               </a:ext>
             </a:extLst>
           </p:cNvPr>
@@ -2177,7 +2177,7 @@
           <p:cNvPr id="4" name="“Could we add Spanish pages&#10;before launch?”">
             <a:extLst xmlns:a="http://schemas.openxmlformats.org/drawingml/2006/main">
               <a:ext uri="{FF2B5EF4-FFF2-40B4-BE49-F238E27FC236}">
-                <a16:creationId xmlns:a16="http://schemas.microsoft.com/office/drawing/2014/main" id="{BDF25BE5-03E0-473E-B012-0A30193C5E67}"/>
+                <a16:creationId xmlns:a16="http://schemas.microsoft.com/office/drawing/2014/main" id="{5BD52EE5-8317-4EAE-90DE-4C1E9624C846}"/>
               </a:ext>
             </a:extLst>
           </p:cNvPr>
@@ -2257,7 +2257,7 @@
           <p:cNvPr id="5" name="A 12-hour request adds $720&#10;of estimated delivery labor">
             <a:extLst xmlns:a="http://schemas.openxmlformats.org/drawingml/2006/main">
               <a:ext uri="{FF2B5EF4-FFF2-40B4-BE49-F238E27FC236}">
-                <a16:creationId xmlns:a16="http://schemas.microsoft.com/office/drawing/2014/main" id="{34920309-EADA-46F3-9CA4-67E8E0077399}"/>
+                <a16:creationId xmlns:a16="http://schemas.microsoft.com/office/drawing/2014/main" id="{37EA3F5C-9ECC-484C-89F3-D440E215C1A1}"/>
               </a:ext>
             </a:extLst>
           </p:cNvPr>
@@ -2337,7 +2337,7 @@
           <p:cNvPr id="6" name="A fixed fee stays fixed until&#10;someone changes the agree">
             <a:extLst xmlns:a="http://schemas.openxmlformats.org/drawingml/2006/main">
               <a:ext uri="{FF2B5EF4-FFF2-40B4-BE49-F238E27FC236}">
-                <a16:creationId xmlns:a16="http://schemas.microsoft.com/office/drawing/2014/main" id="{7F7DB79A-C515-4DB6-BC0C-AF4E48F17390}"/>
+                <a16:creationId xmlns:a16="http://schemas.microsoft.com/office/drawing/2014/main" id="{761880AD-1152-4521-A546-EE858CE30E2E}"/>
               </a:ext>
             </a:extLst>
           </p:cNvPr>
@@ -2424,7 +2424,7 @@
         </p:xfrm>
         <a:graphic xmlns:a="http://schemas.openxmlformats.org/drawingml/2006/main">
           <a:graphicData uri="http://schemas.openxmlformats.org/drawingml/2006/chart">
-            <c:chart xmlns:r="http://schemas.openxmlformats.org/officeDocument/2006/relationships" xmlns:c="http://schemas.openxmlformats.org/drawingml/2006/chart" r:id="R1a4829e784274ba5"/>
+            <c:chart xmlns:r="http://schemas.openxmlformats.org/officeDocument/2006/relationships" xmlns:c="http://schemas.openxmlformats.org/drawingml/2006/chart" r:id="R71500f5795774647"/>
           </a:graphicData>
         </a:graphic>
       </p:graphicFrame>
@@ -2433,7 +2433,7 @@
           <p:cNvPr id="8" name="Margin after delivery labor (illustrative)">
             <a:extLst xmlns:a="http://schemas.openxmlformats.org/drawingml/2006/main">
               <a:ext uri="{FF2B5EF4-FFF2-40B4-BE49-F238E27FC236}">
-                <a16:creationId xmlns:a16="http://schemas.microsoft.com/office/drawing/2014/main" id="{CBC71316-CC29-4ACE-909B-EE1AD3A3AF88}"/>
+                <a16:creationId xmlns:a16="http://schemas.microsoft.com/office/drawing/2014/main" id="{5016B2F2-F67C-4DDB-9878-70FE1E566D4D}"/>
               </a:ext>
             </a:extLst>
           </p:cNvPr>
@@ -2490,7 +2490,7 @@
           <p:cNvPr id="9" name="$12,000 fee, 96h at $60/h delivery cost.">
             <a:extLst xmlns:a="http://schemas.openxmlformats.org/drawingml/2006/main">
               <a:ext uri="{FF2B5EF4-FFF2-40B4-BE49-F238E27FC236}">
-                <a16:creationId xmlns:a16="http://schemas.microsoft.com/office/drawing/2014/main" id="{EF9EA3B1-0B53-4F07-B4EB-A4C1459A4AE3}"/>
+                <a16:creationId xmlns:a16="http://schemas.microsoft.com/office/drawing/2014/main" id="{B3DD8632-8C8D-4BED-ABE7-A79CFD502776}"/>
               </a:ext>
             </a:extLst>
           </p:cNvPr>
@@ -2545,7 +2545,7 @@
     </p:spTree>
     <p:extLst>
       <p:ext uri="{BB962C8B-B14F-4D97-AF65-F5344CB8AC3E}">
-        <p14:creationId xmlns:p14="http://schemas.microsoft.com/office/powerpoint/2010/main" val="389234701"/>
+        <p14:creationId xmlns:p14="http://schemas.microsoft.com/office/powerpoint/2010/main" val="629771129"/>
       </p:ext>
     </p:extLst>
   </p:cSld>
@@ -2576,7 +2576,7 @@
           <p:cNvPr id="7" name="PACTSHIFT">
             <a:extLst xmlns:a="http://schemas.openxmlformats.org/drawingml/2006/main">
               <a:ext uri="{FF2B5EF4-FFF2-40B4-BE49-F238E27FC236}">
-                <a16:creationId xmlns:a16="http://schemas.microsoft.com/office/drawing/2014/main" id="{50B12909-0CF7-4292-BD6D-1DEFEC33528C}"/>
+                <a16:creationId xmlns:a16="http://schemas.microsoft.com/office/drawing/2014/main" id="{32068A6E-7A19-4B8F-805D-1FB618002C4B}"/>
               </a:ext>
             </a:extLst>
           </p:cNvPr>
@@ -2633,7 +2633,7 @@
           <p:cNvPr id="2" name="03">
             <a:extLst xmlns:a="http://schemas.openxmlformats.org/drawingml/2006/main">
               <a:ext uri="{FF2B5EF4-FFF2-40B4-BE49-F238E27FC236}">
-                <a16:creationId xmlns:a16="http://schemas.microsoft.com/office/drawing/2014/main" id="{5B1DABE6-EC23-4603-A0CA-9D7F087C5F89}"/>
+                <a16:creationId xmlns:a16="http://schemas.microsoft.com/office/drawing/2014/main" id="{E35B709E-FEFD-4A53-BE88-33B67AB79645}"/>
               </a:ext>
             </a:extLst>
           </p:cNvPr>
@@ -2690,7 +2690,7 @@
           <p:cNvPr id="3" name="A request becomes a clear choice">
             <a:extLst xmlns:a="http://schemas.openxmlformats.org/drawingml/2006/main">
               <a:ext uri="{FF2B5EF4-FFF2-40B4-BE49-F238E27FC236}">
-                <a16:creationId xmlns:a16="http://schemas.microsoft.com/office/drawing/2014/main" id="{013A20D9-1DC7-4892-9606-C3822DCE5BD4}"/>
+                <a16:creationId xmlns:a16="http://schemas.microsoft.com/office/drawing/2014/main" id="{0905C9A5-344B-484F-B915-F064E1219BAE}"/>
               </a:ext>
             </a:extLst>
           </p:cNvPr>
@@ -3066,7 +3066,7 @@
           <p:cNvPr id="5" name="Pactshift applies the accepted choice to the project ba">
             <a:extLst xmlns:a="http://schemas.openxmlformats.org/drawingml/2006/main">
               <a:ext uri="{FF2B5EF4-FFF2-40B4-BE49-F238E27FC236}">
-                <a16:creationId xmlns:a16="http://schemas.microsoft.com/office/drawing/2014/main" id="{7FC221DF-F425-4052-9DCD-7F9FD6887E18}"/>
+                <a16:creationId xmlns:a16="http://schemas.microsoft.com/office/drawing/2014/main" id="{AEF66705-7C73-4E63-9773-3FD846426475}"/>
               </a:ext>
             </a:extLst>
           </p:cNvPr>
@@ -3123,7 +3123,7 @@
           <p:cNvPr id="6" name="A share link records the decision. Version checks stop ">
             <a:extLst xmlns:a="http://schemas.openxmlformats.org/drawingml/2006/main">
               <a:ext uri="{FF2B5EF4-FFF2-40B4-BE49-F238E27FC236}">
-                <a16:creationId xmlns:a16="http://schemas.microsoft.com/office/drawing/2014/main" id="{58DC3A64-1682-4FBF-AEAF-541D0D4DE211}"/>
+                <a16:creationId xmlns:a16="http://schemas.microsoft.com/office/drawing/2014/main" id="{DF569208-F221-4C3D-A128-D8516059AC6C}"/>
               </a:ext>
             </a:extLst>
           </p:cNvPr>
@@ -3178,7 +3178,7 @@
     </p:spTree>
     <p:extLst>
       <p:ext uri="{BB962C8B-B14F-4D97-AF65-F5344CB8AC3E}">
-        <p14:creationId xmlns:p14="http://schemas.microsoft.com/office/powerpoint/2010/main" val="237889287"/>
+        <p14:creationId xmlns:p14="http://schemas.microsoft.com/office/powerpoint/2010/main" val="1773640903"/>
       </p:ext>
     </p:extLst>
   </p:cSld>
@@ -3209,7 +3209,7 @@
           <p:cNvPr id="6" name="PACTSHIFT">
             <a:extLst xmlns:a="http://schemas.openxmlformats.org/drawingml/2006/main">
               <a:ext uri="{FF2B5EF4-FFF2-40B4-BE49-F238E27FC236}">
-                <a16:creationId xmlns:a16="http://schemas.microsoft.com/office/drawing/2014/main" id="{9792C718-5496-44BB-A232-7DCAD8E3F683}"/>
+                <a16:creationId xmlns:a16="http://schemas.microsoft.com/office/drawing/2014/main" id="{F3743684-DC0B-43EB-A625-089BCD1B12BB}"/>
               </a:ext>
             </a:extLst>
           </p:cNvPr>
@@ -3266,7 +3266,7 @@
           <p:cNvPr id="2" name="04">
             <a:extLst xmlns:a="http://schemas.openxmlformats.org/drawingml/2006/main">
               <a:ext uri="{FF2B5EF4-FFF2-40B4-BE49-F238E27FC236}">
-                <a16:creationId xmlns:a16="http://schemas.microsoft.com/office/drawing/2014/main" id="{A0C05BE2-6B69-44DC-8A99-C3F256BBE96F}"/>
+                <a16:creationId xmlns:a16="http://schemas.microsoft.com/office/drawing/2014/main" id="{98D4AE93-7164-4B1D-8574-6045F69BB2F3}"/>
               </a:ext>
             </a:extLst>
           </p:cNvPr>
@@ -3323,7 +3323,7 @@
           <p:cNvPr id="3" name="The request beside the agreement">
             <a:extLst xmlns:a="http://schemas.openxmlformats.org/drawingml/2006/main">
               <a:ext uri="{FF2B5EF4-FFF2-40B4-BE49-F238E27FC236}">
-                <a16:creationId xmlns:a16="http://schemas.microsoft.com/office/drawing/2014/main" id="{D3AA4292-400E-4460-9DD0-CA81B66E4806}"/>
+                <a16:creationId xmlns:a16="http://schemas.microsoft.com/office/drawing/2014/main" id="{A8253DDB-0FD4-45E5-93BA-5983FCF9BDA6}"/>
               </a:ext>
             </a:extLst>
           </p:cNvPr>
@@ -3384,7 +3384,7 @@
           <p:nvPr/>
         </p:nvPicPr>
         <p:blipFill>
-          <a:blip xmlns:r="http://schemas.openxmlformats.org/officeDocument/2006/relationships" xmlns:a="http://schemas.openxmlformats.org/drawingml/2006/main" r:embed="R28f5cadee4c84c91"/>
+          <a:blip xmlns:r="http://schemas.openxmlformats.org/officeDocument/2006/relationships" xmlns:a="http://schemas.openxmlformats.org/drawingml/2006/main" r:embed="R2db6fcfa96b84f89"/>
           <a:stretch xmlns:a="http://schemas.openxmlformats.org/drawingml/2006/main"/>
         </p:blipFill>
         <p:spPr>
@@ -3402,7 +3402,7 @@
           <p:cNvPr id="5" name="Actual product workflow using a fictional demonstration">
             <a:extLst xmlns:a="http://schemas.openxmlformats.org/drawingml/2006/main">
               <a:ext uri="{FF2B5EF4-FFF2-40B4-BE49-F238E27FC236}">
-                <a16:creationId xmlns:a16="http://schemas.microsoft.com/office/drawing/2014/main" id="{C71592FD-44F7-46A9-99FC-CE9638E00A6E}"/>
+                <a16:creationId xmlns:a16="http://schemas.microsoft.com/office/drawing/2014/main" id="{37B30075-9C9C-4C99-8AFB-B4C2AF1555F3}"/>
               </a:ext>
             </a:extLst>
           </p:cNvPr>
@@ -3457,7 +3457,7 @@
     </p:spTree>
     <p:extLst>
       <p:ext uri="{BB962C8B-B14F-4D97-AF65-F5344CB8AC3E}">
-        <p14:creationId xmlns:p14="http://schemas.microsoft.com/office/powerpoint/2010/main" val="889751383"/>
+        <p14:creationId xmlns:p14="http://schemas.microsoft.com/office/powerpoint/2010/main" val="20897689"/>
       </p:ext>
     </p:extLst>
   </p:cSld>
@@ -3488,7 +3488,7 @@
           <p:cNvPr id="15" name="PACTSHIFT">
             <a:extLst xmlns:a="http://schemas.openxmlformats.org/drawingml/2006/main">
               <a:ext uri="{FF2B5EF4-FFF2-40B4-BE49-F238E27FC236}">
-                <a16:creationId xmlns:a16="http://schemas.microsoft.com/office/drawing/2014/main" id="{BAABBFE0-44F2-428C-865E-5D107D66F512}"/>
+                <a16:creationId xmlns:a16="http://schemas.microsoft.com/office/drawing/2014/main" id="{0ABEE82B-FA03-4DBC-89B4-1106156644D2}"/>
               </a:ext>
             </a:extLst>
           </p:cNvPr>
@@ -3545,7 +3545,7 @@
           <p:cNvPr id="2" name="05">
             <a:extLst xmlns:a="http://schemas.openxmlformats.org/drawingml/2006/main">
               <a:ext uri="{FF2B5EF4-FFF2-40B4-BE49-F238E27FC236}">
-                <a16:creationId xmlns:a16="http://schemas.microsoft.com/office/drawing/2014/main" id="{4EBB639A-AB76-470E-AEE2-CCECA7DEE1F4}"/>
+                <a16:creationId xmlns:a16="http://schemas.microsoft.com/office/drawing/2014/main" id="{D6160DB9-1950-498C-AF23-E5E552EC9A45}"/>
               </a:ext>
             </a:extLst>
           </p:cNvPr>
@@ -3602,7 +3602,7 @@
           <p:cNvPr id="3" name="An approval changes the system">
             <a:extLst xmlns:a="http://schemas.openxmlformats.org/drawingml/2006/main">
               <a:ext uri="{FF2B5EF4-FFF2-40B4-BE49-F238E27FC236}">
-                <a16:creationId xmlns:a16="http://schemas.microsoft.com/office/drawing/2014/main" id="{E6E70E32-18D5-48A6-9A8A-57CBB3008411}"/>
+                <a16:creationId xmlns:a16="http://schemas.microsoft.com/office/drawing/2014/main" id="{778940E6-AB40-4CDF-8562-A9F958FD3976}"/>
               </a:ext>
             </a:extLst>
           </p:cNvPr>
@@ -3659,7 +3659,7 @@
           <p:cNvPr id="4" name="01">
             <a:extLst xmlns:a="http://schemas.openxmlformats.org/drawingml/2006/main">
               <a:ext uri="{FF2B5EF4-FFF2-40B4-BE49-F238E27FC236}">
-                <a16:creationId xmlns:a16="http://schemas.microsoft.com/office/drawing/2014/main" id="{967FB4FC-BBF0-4DAE-94C8-AEC6854E8E70}"/>
+                <a16:creationId xmlns:a16="http://schemas.microsoft.com/office/drawing/2014/main" id="{348E4477-2B5E-403E-A2A5-E396C3EC2175}"/>
               </a:ext>
             </a:extLst>
           </p:cNvPr>
@@ -3716,7 +3716,7 @@
           <p:cNvPr id="5" name="Review">
             <a:extLst xmlns:a="http://schemas.openxmlformats.org/drawingml/2006/main">
               <a:ext uri="{FF2B5EF4-FFF2-40B4-BE49-F238E27FC236}">
-                <a16:creationId xmlns:a16="http://schemas.microsoft.com/office/drawing/2014/main" id="{70837B72-3427-4F3D-ACF5-DF685D830585}"/>
+                <a16:creationId xmlns:a16="http://schemas.microsoft.com/office/drawing/2014/main" id="{73B62710-25FD-4B30-96EF-F5A863153ED9}"/>
               </a:ext>
             </a:extLst>
           </p:cNvPr>
@@ -3773,7 +3773,7 @@
           <p:cNvPr id="6" name="02">
             <a:extLst xmlns:a="http://schemas.openxmlformats.org/drawingml/2006/main">
               <a:ext uri="{FF2B5EF4-FFF2-40B4-BE49-F238E27FC236}">
-                <a16:creationId xmlns:a16="http://schemas.microsoft.com/office/drawing/2014/main" id="{30FB5A64-9AEE-4252-A27F-AF966C4B0826}"/>
+                <a16:creationId xmlns:a16="http://schemas.microsoft.com/office/drawing/2014/main" id="{D407449D-1ACF-4196-AEBA-BCAB9FF927AF}"/>
               </a:ext>
             </a:extLst>
           </p:cNvPr>
@@ -3830,7 +3830,7 @@
           <p:cNvPr id="7" name="Validate">
             <a:extLst xmlns:a="http://schemas.openxmlformats.org/drawingml/2006/main">
               <a:ext uri="{FF2B5EF4-FFF2-40B4-BE49-F238E27FC236}">
-                <a16:creationId xmlns:a16="http://schemas.microsoft.com/office/drawing/2014/main" id="{53A59458-B34A-4861-BB0B-793AE98B0A6C}"/>
+                <a16:creationId xmlns:a16="http://schemas.microsoft.com/office/drawing/2014/main" id="{DB3C1F66-79CF-4B38-B47F-4F64BAA663BD}"/>
               </a:ext>
             </a:extLst>
           </p:cNvPr>
@@ -3887,7 +3887,7 @@
           <p:cNvPr id="8" name="03">
             <a:extLst xmlns:a="http://schemas.openxmlformats.org/drawingml/2006/main">
               <a:ext uri="{FF2B5EF4-FFF2-40B4-BE49-F238E27FC236}">
-                <a16:creationId xmlns:a16="http://schemas.microsoft.com/office/drawing/2014/main" id="{3A2654BC-D75B-4DF8-8149-11A5B87109DF}"/>
+                <a16:creationId xmlns:a16="http://schemas.microsoft.com/office/drawing/2014/main" id="{6BA64EB3-33DA-44FD-BAFA-55D6928B8CE0}"/>
               </a:ext>
             </a:extLst>
           </p:cNvPr>
@@ -3944,7 +3944,7 @@
           <p:cNvPr id="9" name="Commit">
             <a:extLst xmlns:a="http://schemas.openxmlformats.org/drawingml/2006/main">
               <a:ext uri="{FF2B5EF4-FFF2-40B4-BE49-F238E27FC236}">
-                <a16:creationId xmlns:a16="http://schemas.microsoft.com/office/drawing/2014/main" id="{015DCA91-FCF4-420E-919C-C5BBFDC26E19}"/>
+                <a16:creationId xmlns:a16="http://schemas.microsoft.com/office/drawing/2014/main" id="{AF3B7A84-731C-4C50-ACA3-72E50DE79C07}"/>
               </a:ext>
             </a:extLst>
           </p:cNvPr>
@@ -4001,7 +4001,7 @@
           <p:cNvPr id="10" name="An agency reviews scope&#10;evidence and effort. The&#10;client">
             <a:extLst xmlns:a="http://schemas.openxmlformats.org/drawingml/2006/main">
               <a:ext uri="{FF2B5EF4-FFF2-40B4-BE49-F238E27FC236}">
-                <a16:creationId xmlns:a16="http://schemas.microsoft.com/office/drawing/2014/main" id="{3072D18B-00C0-4E73-ABE0-07780424DD7E}"/>
+                <a16:creationId xmlns:a16="http://schemas.microsoft.com/office/drawing/2014/main" id="{80FD1422-CDBC-4B41-A814-4401CCD61CC6}"/>
               </a:ext>
             </a:extLst>
           </p:cNvPr>
@@ -4104,7 +4104,7 @@
           <p:cNvPr id="11" name="The API checks tenant,&#10;price, capacity, expiry&#10;and base">
             <a:extLst xmlns:a="http://schemas.openxmlformats.org/drawingml/2006/main">
               <a:ext uri="{FF2B5EF4-FFF2-40B4-BE49-F238E27FC236}">
-                <a16:creationId xmlns:a16="http://schemas.microsoft.com/office/drawing/2014/main" id="{D59B4E8F-6817-489B-8742-DF4ECA9D44CC}"/>
+                <a16:creationId xmlns:a16="http://schemas.microsoft.com/office/drawing/2014/main" id="{0B75F1F9-C636-4597-82AC-0D337A16EF3A}"/>
               </a:ext>
             </a:extLst>
           </p:cNvPr>
@@ -4207,7 +4207,7 @@
           <p:cNvPr id="12" name="One transaction updates&#10;the baseline and records&#10;the au">
             <a:extLst xmlns:a="http://schemas.openxmlformats.org/drawingml/2006/main">
               <a:ext uri="{FF2B5EF4-FFF2-40B4-BE49-F238E27FC236}">
-                <a16:creationId xmlns:a16="http://schemas.microsoft.com/office/drawing/2014/main" id="{86A16C52-D4EA-4FB1-9234-492071079A71}"/>
+                <a16:creationId xmlns:a16="http://schemas.microsoft.com/office/drawing/2014/main" id="{0160AF84-7A99-4108-977D-6174AC311E4C}"/>
               </a:ext>
             </a:extLst>
           </p:cNvPr>
@@ -4310,7 +4310,7 @@
           <p:cNvPr id="13" name="">
             <a:extLst xmlns:a="http://schemas.openxmlformats.org/drawingml/2006/main">
               <a:ext uri="{FF2B5EF4-FFF2-40B4-BE49-F238E27FC236}">
-                <a16:creationId xmlns:a16="http://schemas.microsoft.com/office/drawing/2014/main" id="{B41D2BA4-838E-48EB-9A7D-60B3CA8866E9}"/>
+                <a16:creationId xmlns:a16="http://schemas.microsoft.com/office/drawing/2014/main" id="{13FB19D6-F984-4941-8904-284B23AD2AA0}"/>
               </a:ext>
             </a:extLst>
           </p:cNvPr>
@@ -4340,7 +4340,7 @@
           <p:cNvPr id="14" name="AI suggests. People decide. The server enforces the agr">
             <a:extLst xmlns:a="http://schemas.openxmlformats.org/drawingml/2006/main">
               <a:ext uri="{FF2B5EF4-FFF2-40B4-BE49-F238E27FC236}">
-                <a16:creationId xmlns:a16="http://schemas.microsoft.com/office/drawing/2014/main" id="{C0DC1274-627F-467E-B486-5CC5CB302948}"/>
+                <a16:creationId xmlns:a16="http://schemas.microsoft.com/office/drawing/2014/main" id="{0C35A42A-ECAF-4BAC-AAAF-DBBDEF4849A9}"/>
               </a:ext>
             </a:extLst>
           </p:cNvPr>
@@ -4395,7 +4395,7 @@
     </p:spTree>
     <p:extLst>
       <p:ext uri="{BB962C8B-B14F-4D97-AF65-F5344CB8AC3E}">
-        <p14:creationId xmlns:p14="http://schemas.microsoft.com/office/powerpoint/2010/main" val="66958705"/>
+        <p14:creationId xmlns:p14="http://schemas.microsoft.com/office/powerpoint/2010/main" val="1836427531"/>
       </p:ext>
     </p:extLst>
   </p:cSld>
@@ -4426,7 +4426,7 @@
           <p:cNvPr id="7" name="PACTSHIFT">
             <a:extLst xmlns:a="http://schemas.openxmlformats.org/drawingml/2006/main">
               <a:ext uri="{FF2B5EF4-FFF2-40B4-BE49-F238E27FC236}">
-                <a16:creationId xmlns:a16="http://schemas.microsoft.com/office/drawing/2014/main" id="{59ADCCCE-DFA4-4E88-88BA-0BBCC1A0A9C2}"/>
+                <a16:creationId xmlns:a16="http://schemas.microsoft.com/office/drawing/2014/main" id="{041C6F0F-CD6D-476D-B7DB-A0D6BBE22368}"/>
               </a:ext>
             </a:extLst>
           </p:cNvPr>
@@ -4483,7 +4483,7 @@
           <p:cNvPr id="2" name="06">
             <a:extLst xmlns:a="http://schemas.openxmlformats.org/drawingml/2006/main">
               <a:ext uri="{FF2B5EF4-FFF2-40B4-BE49-F238E27FC236}">
-                <a16:creationId xmlns:a16="http://schemas.microsoft.com/office/drawing/2014/main" id="{8B10645F-18F8-4D0B-BC66-77D40BF4EC8F}"/>
+                <a16:creationId xmlns:a16="http://schemas.microsoft.com/office/drawing/2014/main" id="{4E1A95C5-0B79-43B7-A0B9-27A4736B5569}"/>
               </a:ext>
             </a:extLst>
           </p:cNvPr>
@@ -4540,7 +4540,7 @@
           <p:cNvPr id="3" name="A flat subscription for each workspace">
             <a:extLst xmlns:a="http://schemas.openxmlformats.org/drawingml/2006/main">
               <a:ext uri="{FF2B5EF4-FFF2-40B4-BE49-F238E27FC236}">
-                <a16:creationId xmlns:a16="http://schemas.microsoft.com/office/drawing/2014/main" id="{4F25EEEB-C4D7-4778-AF18-BC9E989CF127}"/>
+                <a16:creationId xmlns:a16="http://schemas.microsoft.com/office/drawing/2014/main" id="{B0A51C25-B546-4B8E-8C39-6C6FC85D9376}"/>
               </a:ext>
             </a:extLst>
           </p:cNvPr>
@@ -5013,7 +5013,7 @@
           <p:cNvPr id="5" name="No percentage fee on the changes a client accepts.">
             <a:extLst xmlns:a="http://schemas.openxmlformats.org/drawingml/2006/main">
               <a:ext uri="{FF2B5EF4-FFF2-40B4-BE49-F238E27FC236}">
-                <a16:creationId xmlns:a16="http://schemas.microsoft.com/office/drawing/2014/main" id="{E3C7F4A5-6330-41C5-BF8E-FD9E220483C4}"/>
+                <a16:creationId xmlns:a16="http://schemas.microsoft.com/office/drawing/2014/main" id="{6EE1A181-4DA1-4A61-B9BC-65C000A8FD66}"/>
               </a:ext>
             </a:extLst>
           </p:cNvPr>
@@ -5070,7 +5070,7 @@
           <p:cNvPr id="6" name="Proposed pricing. Archived projects count toward the li">
             <a:extLst xmlns:a="http://schemas.openxmlformats.org/drawingml/2006/main">
               <a:ext uri="{FF2B5EF4-FFF2-40B4-BE49-F238E27FC236}">
-                <a16:creationId xmlns:a16="http://schemas.microsoft.com/office/drawing/2014/main" id="{DC532545-BAB0-427B-8C7E-CCCF50DE5E08}"/>
+                <a16:creationId xmlns:a16="http://schemas.microsoft.com/office/drawing/2014/main" id="{E397DC64-4E77-4E0A-8040-982567F8571D}"/>
               </a:ext>
             </a:extLst>
           </p:cNvPr>
@@ -5125,7 +5125,7 @@
     </p:spTree>
     <p:extLst>
       <p:ext uri="{BB962C8B-B14F-4D97-AF65-F5344CB8AC3E}">
-        <p14:creationId xmlns:p14="http://schemas.microsoft.com/office/powerpoint/2010/main" val="19844975"/>
+        <p14:creationId xmlns:p14="http://schemas.microsoft.com/office/powerpoint/2010/main" val="1375882875"/>
       </p:ext>
     </p:extLst>
   </p:cSld>
@@ -5156,7 +5156,7 @@
           <p:cNvPr id="10" name="PACTSHIFT">
             <a:extLst xmlns:a="http://schemas.openxmlformats.org/drawingml/2006/main">
               <a:ext uri="{FF2B5EF4-FFF2-40B4-BE49-F238E27FC236}">
-                <a16:creationId xmlns:a16="http://schemas.microsoft.com/office/drawing/2014/main" id="{DEAB32BA-98CB-402D-B7F7-856DB6962364}"/>
+                <a16:creationId xmlns:a16="http://schemas.microsoft.com/office/drawing/2014/main" id="{37D8EAD2-0AAC-4BD8-A953-567888A87AB8}"/>
               </a:ext>
             </a:extLst>
           </p:cNvPr>
@@ -5213,7 +5213,7 @@
           <p:cNvPr id="2" name="07">
             <a:extLst xmlns:a="http://schemas.openxmlformats.org/drawingml/2006/main">
               <a:ext uri="{FF2B5EF4-FFF2-40B4-BE49-F238E27FC236}">
-                <a16:creationId xmlns:a16="http://schemas.microsoft.com/office/drawing/2014/main" id="{8A5C4F12-6571-4E13-8ABC-3A16163231F2}"/>
+                <a16:creationId xmlns:a16="http://schemas.microsoft.com/office/drawing/2014/main" id="{7D01E5F3-7509-4379-89BB-42DD8A6C7752}"/>
               </a:ext>
             </a:extLst>
           </p:cNvPr>
@@ -5270,7 +5270,7 @@
           <p:cNvPr id="3" name="Built for the next&#10;fixed-fee change">
             <a:extLst xmlns:a="http://schemas.openxmlformats.org/drawingml/2006/main">
               <a:ext uri="{FF2B5EF4-FFF2-40B4-BE49-F238E27FC236}">
-                <a16:creationId xmlns:a16="http://schemas.microsoft.com/office/drawing/2014/main" id="{1E3B48C8-0627-44EE-864B-09070CA556D0}"/>
+                <a16:creationId xmlns:a16="http://schemas.microsoft.com/office/drawing/2014/main" id="{F655B437-A6E3-4AC1-9CFB-E57958C9C5C8}"/>
               </a:ext>
             </a:extLst>
           </p:cNvPr>
@@ -5350,7 +5350,7 @@
           <p:cNvPr id="4" name="Initial buyer">
             <a:extLst xmlns:a="http://schemas.openxmlformats.org/drawingml/2006/main">
               <a:ext uri="{FF2B5EF4-FFF2-40B4-BE49-F238E27FC236}">
-                <a16:creationId xmlns:a16="http://schemas.microsoft.com/office/drawing/2014/main" id="{313A2CA7-86BF-445C-9ACD-7F74D115E5FA}"/>
+                <a16:creationId xmlns:a16="http://schemas.microsoft.com/office/drawing/2014/main" id="{53508031-CC02-4067-94B4-3999FF8D1E7C}"/>
               </a:ext>
             </a:extLst>
           </p:cNvPr>
@@ -5407,7 +5407,7 @@
           <p:cNvPr id="5" name="Small web and design agencies&#10;with repeated scope negot">
             <a:extLst xmlns:a="http://schemas.openxmlformats.org/drawingml/2006/main">
               <a:ext uri="{FF2B5EF4-FFF2-40B4-BE49-F238E27FC236}">
-                <a16:creationId xmlns:a16="http://schemas.microsoft.com/office/drawing/2014/main" id="{791D6380-7DCE-47A8-9C4D-1B99C70B65F4}"/>
+                <a16:creationId xmlns:a16="http://schemas.microsoft.com/office/drawing/2014/main" id="{9283CFE0-0AF2-4A18-B9E1-B036B320848E}"/>
               </a:ext>
             </a:extLst>
           </p:cNvPr>
@@ -5487,7 +5487,7 @@
           <p:cNvPr id="6" name="Validation plan">
             <a:extLst xmlns:a="http://schemas.openxmlformats.org/drawingml/2006/main">
               <a:ext uri="{FF2B5EF4-FFF2-40B4-BE49-F238E27FC236}">
-                <a16:creationId xmlns:a16="http://schemas.microsoft.com/office/drawing/2014/main" id="{644869C3-EFEE-4FA7-BBF7-1747519BDC73}"/>
+                <a16:creationId xmlns:a16="http://schemas.microsoft.com/office/drawing/2014/main" id="{1A1D7BF3-B4A1-4557-867C-FA15D09E6072}"/>
               </a:ext>
             </a:extLst>
           </p:cNvPr>
@@ -5544,7 +5544,7 @@
           <p:cNvPr id="7" name="Five design partners using real&#10;requests. Measure paid ">
             <a:extLst xmlns:a="http://schemas.openxmlformats.org/drawingml/2006/main">
               <a:ext uri="{FF2B5EF4-FFF2-40B4-BE49-F238E27FC236}">
-                <a16:creationId xmlns:a16="http://schemas.microsoft.com/office/drawing/2014/main" id="{55073570-44AB-4AEF-A754-CA0E1451B271}"/>
+                <a16:creationId xmlns:a16="http://schemas.microsoft.com/office/drawing/2014/main" id="{FBBD0D14-6235-49FA-AFC0-50281DE9233A}"/>
               </a:ext>
             </a:extLst>
           </p:cNvPr>
@@ -5647,7 +5647,7 @@
           <p:cNvPr id="8" name="Shivam Gupta  /  Founder and builder">
             <a:extLst xmlns:a="http://schemas.openxmlformats.org/drawingml/2006/main">
               <a:ext uri="{FF2B5EF4-FFF2-40B4-BE49-F238E27FC236}">
-                <a16:creationId xmlns:a16="http://schemas.microsoft.com/office/drawing/2014/main" id="{B5BA87C6-5716-46E4-94B2-42F913BD8467}"/>
+                <a16:creationId xmlns:a16="http://schemas.microsoft.com/office/drawing/2014/main" id="{3D300DFC-37B8-4015-9752-66077656A1B4}"/>
               </a:ext>
             </a:extLst>
           </p:cNvPr>
@@ -5701,10 +5701,10 @@
       </p:sp>
       <p:sp>
         <p:nvSpPr>
-          <p:cNvPr id="9" name="pactshift-wh46bdeima-uc.a.run.app">
+          <p:cNvPr id="9" name="pactshift.web.app">
             <a:extLst xmlns:a="http://schemas.openxmlformats.org/drawingml/2006/main">
               <a:ext uri="{FF2B5EF4-FFF2-40B4-BE49-F238E27FC236}">
-                <a16:creationId xmlns:a16="http://schemas.microsoft.com/office/drawing/2014/main" id="{2E2259CD-D0D2-4D4A-B1A5-567EBF7D68EB}"/>
+                <a16:creationId xmlns:a16="http://schemas.microsoft.com/office/drawing/2014/main" id="{8985697A-4E0B-461E-94DC-A2DA1AEE48F2}"/>
               </a:ext>
             </a:extLst>
           </p:cNvPr>
@@ -5751,7 +5751,7 @@
                 <a:ea typeface="Arial"/>
                 <a:cs typeface="Arial"/>
               </a:rPr>
-              <a:t>pactshift-wh46bdeima-uc.a.run.app</a:t>
+              <a:t>pactshift.web.app</a:t>
             </a:r>
           </a:p>
         </p:txBody>
@@ -5759,7 +5759,7 @@
     </p:spTree>
     <p:extLst>
       <p:ext uri="{BB962C8B-B14F-4D97-AF65-F5344CB8AC3E}">
-        <p14:creationId xmlns:p14="http://schemas.microsoft.com/office/powerpoint/2010/main" val="1997099498"/>
+        <p14:creationId xmlns:p14="http://schemas.microsoft.com/office/powerpoint/2010/main" val="1360869340"/>
       </p:ext>
     </p:extLst>
   </p:cSld>

</xml_diff>